<commit_message>
Split 2025 history into H1 (holding-led) and H2 (self-driven) on AX gap slide
Co-Authored-By: Claude Opus 5.5 <noreply@anthropic.com>
Claude-Session: https://claude.ai/code/session_01QouM6Vu5RyUNEDj5BHo7fD
</commit_message>
<xml_diff>
--- a/AX_Operation_Gap.pptx
+++ b/AX_Operation_Gap.pptx
@@ -1026,7 +1026,7 @@
         <p:spPr>
           <a:xfrm>
             <a:off x="365760" y="1828800"/>
-            <a:ext cx="1085850" cy="658368"/>
+            <a:ext cx="1085850" cy="512064"/>
           </a:xfrm>
           <a:prstGeom prst="rect">
             <a:avLst/>
@@ -1050,8 +1050,8 @@
         </p:nvSpPr>
         <p:spPr>
           <a:xfrm>
-            <a:off x="365760" y="1856232"/>
-            <a:ext cx="1085850" cy="365760"/>
+            <a:off x="365760" y="1847088"/>
+            <a:ext cx="1085850" cy="292608"/>
           </a:xfrm>
           <a:prstGeom prst="rect">
             <a:avLst/>
@@ -1067,7 +1067,7 @@
               <a:buNone/>
             </a:pPr>
             <a:r>
-              <a:rPr lang="en-US" sz="2000" b="1" dirty="0">
+              <a:rPr lang="en-US" sz="1700" b="1" dirty="0">
                 <a:solidFill>
                   <a:srgbClr val="D7281E"/>
                 </a:solidFill>
@@ -1077,7 +1077,7 @@
               </a:rPr>
               <a:t>22건</a:t>
             </a:r>
-            <a:endParaRPr lang="en-US" sz="2000" dirty="0"/>
+            <a:endParaRPr lang="en-US" sz="1700" dirty="0"/>
           </a:p>
         </p:txBody>
       </p:sp>
@@ -1089,8 +1089,8 @@
         </p:nvSpPr>
         <p:spPr>
           <a:xfrm>
-            <a:off x="365760" y="2212848"/>
-            <a:ext cx="1085850" cy="228600"/>
+            <a:off x="365760" y="2121408"/>
+            <a:ext cx="1085850" cy="182880"/>
           </a:xfrm>
           <a:prstGeom prst="rect">
             <a:avLst/>
@@ -1129,7 +1129,7 @@
         <p:spPr>
           <a:xfrm>
             <a:off x="1543050" y="1828800"/>
-            <a:ext cx="1085850" cy="658368"/>
+            <a:ext cx="1085850" cy="512064"/>
           </a:xfrm>
           <a:prstGeom prst="rect">
             <a:avLst/>
@@ -1153,8 +1153,8 @@
         </p:nvSpPr>
         <p:spPr>
           <a:xfrm>
-            <a:off x="1543050" y="1856232"/>
-            <a:ext cx="1085850" cy="365760"/>
+            <a:off x="1543050" y="1847088"/>
+            <a:ext cx="1085850" cy="292608"/>
           </a:xfrm>
           <a:prstGeom prst="rect">
             <a:avLst/>
@@ -1170,7 +1170,7 @@
               <a:buNone/>
             </a:pPr>
             <a:r>
-              <a:rPr lang="en-US" sz="2000" b="1" dirty="0">
+              <a:rPr lang="en-US" sz="1700" b="1" dirty="0">
                 <a:solidFill>
                   <a:srgbClr val="3A3A3A"/>
                 </a:solidFill>
@@ -1180,7 +1180,7 @@
               </a:rPr>
               <a:t>19건</a:t>
             </a:r>
-            <a:endParaRPr lang="en-US" sz="2000" dirty="0"/>
+            <a:endParaRPr lang="en-US" sz="1700" dirty="0"/>
           </a:p>
         </p:txBody>
       </p:sp>
@@ -1192,8 +1192,8 @@
         </p:nvSpPr>
         <p:spPr>
           <a:xfrm>
-            <a:off x="1543050" y="2212848"/>
-            <a:ext cx="1085850" cy="228600"/>
+            <a:off x="1543050" y="2121408"/>
+            <a:ext cx="1085850" cy="182880"/>
           </a:xfrm>
           <a:prstGeom prst="rect">
             <a:avLst/>
@@ -1232,7 +1232,7 @@
         <p:spPr>
           <a:xfrm>
             <a:off x="2720340" y="1828800"/>
-            <a:ext cx="1085850" cy="658368"/>
+            <a:ext cx="1085850" cy="512064"/>
           </a:xfrm>
           <a:prstGeom prst="rect">
             <a:avLst/>
@@ -1256,8 +1256,8 @@
         </p:nvSpPr>
         <p:spPr>
           <a:xfrm>
-            <a:off x="2720340" y="1856232"/>
-            <a:ext cx="1085850" cy="365760"/>
+            <a:off x="2720340" y="1847088"/>
+            <a:ext cx="1085850" cy="292608"/>
           </a:xfrm>
           <a:prstGeom prst="rect">
             <a:avLst/>
@@ -1273,7 +1273,7 @@
               <a:buNone/>
             </a:pPr>
             <a:r>
-              <a:rPr lang="en-US" sz="2000" b="1" dirty="0">
+              <a:rPr lang="en-US" sz="1700" b="1" dirty="0">
                 <a:solidFill>
                   <a:srgbClr val="3A3A3A"/>
                 </a:solidFill>
@@ -1283,7 +1283,7 @@
               </a:rPr>
               <a:t>3건</a:t>
             </a:r>
-            <a:endParaRPr lang="en-US" sz="2000" dirty="0"/>
+            <a:endParaRPr lang="en-US" sz="1700" dirty="0"/>
           </a:p>
         </p:txBody>
       </p:sp>
@@ -1295,8 +1295,8 @@
         </p:nvSpPr>
         <p:spPr>
           <a:xfrm>
-            <a:off x="2720340" y="2212848"/>
-            <a:ext cx="1085850" cy="228600"/>
+            <a:off x="2720340" y="2121408"/>
+            <a:ext cx="1085850" cy="182880"/>
           </a:xfrm>
           <a:prstGeom prst="rect">
             <a:avLst/>
@@ -1335,7 +1335,7 @@
         <p:spPr>
           <a:xfrm>
             <a:off x="3897630" y="1828800"/>
-            <a:ext cx="1085850" cy="658368"/>
+            <a:ext cx="1085850" cy="512064"/>
           </a:xfrm>
           <a:prstGeom prst="rect">
             <a:avLst/>
@@ -1359,8 +1359,8 @@
         </p:nvSpPr>
         <p:spPr>
           <a:xfrm>
-            <a:off x="3897630" y="1856232"/>
-            <a:ext cx="1085850" cy="365760"/>
+            <a:off x="3897630" y="1847088"/>
+            <a:ext cx="1085850" cy="292608"/>
           </a:xfrm>
           <a:prstGeom prst="rect">
             <a:avLst/>
@@ -1376,7 +1376,7 @@
               <a:buNone/>
             </a:pPr>
             <a:r>
-              <a:rPr lang="en-US" sz="2000" b="1" dirty="0">
+              <a:rPr lang="en-US" sz="1700" b="1" dirty="0">
                 <a:solidFill>
                   <a:srgbClr val="3A3A3A"/>
                 </a:solidFill>
@@ -1386,7 +1386,7 @@
               </a:rPr>
               <a:t>12명</a:t>
             </a:r>
-            <a:endParaRPr lang="en-US" sz="2000" dirty="0"/>
+            <a:endParaRPr lang="en-US" sz="1700" dirty="0"/>
           </a:p>
         </p:txBody>
       </p:sp>
@@ -1398,8 +1398,8 @@
         </p:nvSpPr>
         <p:spPr>
           <a:xfrm>
-            <a:off x="3897630" y="2212848"/>
-            <a:ext cx="1085850" cy="228600"/>
+            <a:off x="3897630" y="2121408"/>
+            <a:ext cx="1085850" cy="182880"/>
           </a:xfrm>
           <a:prstGeom prst="rect">
             <a:avLst/>
@@ -1437,8 +1437,8 @@
         </p:nvSpPr>
         <p:spPr>
           <a:xfrm>
-            <a:off x="658368" y="2816352"/>
-            <a:ext cx="0" cy="3017520"/>
+            <a:off x="658368" y="2633472"/>
+            <a:ext cx="0" cy="2779776"/>
           </a:xfrm>
           <a:prstGeom prst="line">
             <a:avLst/>
@@ -1460,7 +1460,7 @@
         </p:nvSpPr>
         <p:spPr>
           <a:xfrm>
-            <a:off x="539496" y="2706624"/>
+            <a:off x="539496" y="2523744"/>
             <a:ext cx="237744" cy="237744"/>
           </a:xfrm>
           <a:prstGeom prst="ellipse">
@@ -1485,7 +1485,7 @@
         </p:nvSpPr>
         <p:spPr>
           <a:xfrm>
-            <a:off x="320040" y="2980944"/>
+            <a:off x="320040" y="2798064"/>
             <a:ext cx="685800" cy="228600"/>
           </a:xfrm>
           <a:prstGeom prst="rect">
@@ -1510,7 +1510,7 @@
                 <a:ea typeface="맑은 고딕" pitchFamily="34" charset="-122"/>
                 <a:cs typeface="맑은 고딕" pitchFamily="34" charset="-120"/>
               </a:rPr>
-              <a:t>2025</a:t>
+              <a:t>'25 상</a:t>
             </a:r>
             <a:endParaRPr lang="en-US" sz="1100" dirty="0"/>
           </a:p>
@@ -1524,8 +1524,8 @@
         </p:nvSpPr>
         <p:spPr>
           <a:xfrm>
-            <a:off x="1051560" y="2633472"/>
-            <a:ext cx="3931920" cy="1335024"/>
+            <a:off x="1051560" y="2450592"/>
+            <a:ext cx="3931920" cy="694944"/>
           </a:xfrm>
           <a:prstGeom prst="rect">
             <a:avLst/>
@@ -1549,7 +1549,7 @@
         </p:nvSpPr>
         <p:spPr>
           <a:xfrm>
-            <a:off x="1161288" y="2697480"/>
+            <a:off x="1161288" y="2514600"/>
             <a:ext cx="3712464" cy="274320"/>
           </a:xfrm>
           <a:prstGeom prst="rect">
@@ -1588,7 +1588,7 @@
                 <a:ea typeface="맑은 고딕" pitchFamily="34" charset="-122"/>
                 <a:cs typeface="맑은 고딕" pitchFamily="34" charset="-120"/>
               </a:rPr>
-              <a:t>(16건)</a:t>
+              <a:t>(7건)</a:t>
             </a:r>
             <a:endParaRPr lang="en-US" sz="1250" dirty="0"/>
           </a:p>
@@ -1602,8 +1602,8 @@
         </p:nvSpPr>
         <p:spPr>
           <a:xfrm>
-            <a:off x="1161288" y="2999232"/>
-            <a:ext cx="3712464" cy="923544"/>
+            <a:off x="1161288" y="2788920"/>
+            <a:ext cx="3712464" cy="329184"/>
           </a:xfrm>
           <a:prstGeom prst="rect">
             <a:avLst/>
@@ -1617,7 +1617,7 @@
           <a:p>
             <a:pPr marL="127000" indent="-127000">
               <a:spcAft>
-                <a:spcPts val="200"/>
+                <a:spcPts val="100"/>
               </a:spcAft>
               <a:buSzPct val="100000"/>
               <a:buChar char="•"/>
@@ -1631,14 +1631,14 @@
                 <a:ea typeface="맑은 고딕" pitchFamily="34" charset="-122"/>
                 <a:cs typeface="맑은 고딕" pitchFamily="34" charset="-120"/>
               </a:rPr>
-              <a:t>지주-LIT 4차수 과제발굴 (호텔·웰푸드·하이마트·마트·GRS·칠성·LGL·케미칼)</a:t>
+              <a:t>지주-LIT 과제발굴 1~3차수 ('25.02~'25.06)</a:t>
             </a:r>
             <a:endParaRPr lang="en-US" sz="1050" dirty="0"/>
           </a:p>
           <a:p>
             <a:pPr marL="127000" indent="-127000">
               <a:spcAft>
-                <a:spcPts val="200"/>
+                <a:spcPts val="100"/>
               </a:spcAft>
               <a:buSzPct val="100000"/>
               <a:buChar char="•"/>
@@ -1652,49 +1652,7 @@
                 <a:ea typeface="맑은 고딕" pitchFamily="34" charset="-122"/>
                 <a:cs typeface="맑은 고딕" pitchFamily="34" charset="-120"/>
               </a:rPr>
-              <a:t>후속 상세화 : 마트-슈퍼 KPI, 호텔 객실요금 최적화</a:t>
-            </a:r>
-            <a:endParaRPr lang="en-US" sz="1050" dirty="0"/>
-          </a:p>
-          <a:p>
-            <a:pPr marL="127000" indent="-127000">
-              <a:spcAft>
-                <a:spcPts val="200"/>
-              </a:spcAft>
-              <a:buSzPct val="100000"/>
-              <a:buChar char="•"/>
-            </a:pPr>
-            <a:r>
-              <a:rPr lang="en-US" sz="1050" dirty="0">
-                <a:solidFill>
-                  <a:srgbClr val="3A3A3A"/>
-                </a:solidFill>
-                <a:latin typeface="맑은 고딕" pitchFamily="34" charset="0"/>
-                <a:ea typeface="맑은 고딕" pitchFamily="34" charset="-122"/>
-                <a:cs typeface="맑은 고딕" pitchFamily="34" charset="-120"/>
-              </a:rPr>
-              <a:t>선제안 : 홈쇼핑 GPU, 코리아세븐, 건설</a:t>
-            </a:r>
-            <a:endParaRPr lang="en-US" sz="1050" dirty="0"/>
-          </a:p>
-          <a:p>
-            <a:pPr marL="127000" indent="-127000">
-              <a:spcAft>
-                <a:spcPts val="200"/>
-              </a:spcAft>
-              <a:buSzPct val="100000"/>
-              <a:buChar char="•"/>
-            </a:pPr>
-            <a:r>
-              <a:rPr lang="en-US" sz="1050" dirty="0">
-                <a:solidFill>
-                  <a:srgbClr val="3A3A3A"/>
-                </a:solidFill>
-                <a:latin typeface="맑은 고딕" pitchFamily="34" charset="0"/>
-                <a:ea typeface="맑은 고딕" pitchFamily="34" charset="-122"/>
-                <a:cs typeface="맑은 고딕" pitchFamily="34" charset="-120"/>
-              </a:rPr>
-              <a:t>대외 : 공항철도, 군인공제회</a:t>
+              <a:t>호텔·웰푸드·하이마트 / 마트·GRS / 칠성·LGL</a:t>
             </a:r>
             <a:endParaRPr lang="en-US" sz="1050" dirty="0"/>
           </a:p>
@@ -1708,7 +1666,7 @@
         </p:nvSpPr>
         <p:spPr>
           <a:xfrm>
-            <a:off x="539496" y="4133088"/>
+            <a:off x="539496" y="3310128"/>
             <a:ext cx="237744" cy="237744"/>
           </a:xfrm>
           <a:prstGeom prst="ellipse">
@@ -1733,7 +1691,7 @@
         </p:nvSpPr>
         <p:spPr>
           <a:xfrm>
-            <a:off x="320040" y="4407408"/>
+            <a:off x="320040" y="3584448"/>
             <a:ext cx="685800" cy="228600"/>
           </a:xfrm>
           <a:prstGeom prst="rect">
@@ -1758,7 +1716,7 @@
                 <a:ea typeface="맑은 고딕" pitchFamily="34" charset="-122"/>
                 <a:cs typeface="맑은 고딕" pitchFamily="34" charset="-120"/>
               </a:rPr>
-              <a:t>'26 상</a:t>
+              <a:t>'25 하</a:t>
             </a:r>
             <a:endParaRPr lang="en-US" sz="1100" dirty="0"/>
           </a:p>
@@ -1772,8 +1730,8 @@
         </p:nvSpPr>
         <p:spPr>
           <a:xfrm>
-            <a:off x="1051560" y="4059936"/>
-            <a:ext cx="3931920" cy="841248"/>
+            <a:off x="1051560" y="3236976"/>
+            <a:ext cx="3931920" cy="1024128"/>
           </a:xfrm>
           <a:prstGeom prst="rect">
             <a:avLst/>
@@ -1797,7 +1755,7 @@
         </p:nvSpPr>
         <p:spPr>
           <a:xfrm>
-            <a:off x="1161288" y="4123944"/>
+            <a:off x="1161288" y="3300984"/>
             <a:ext cx="3712464" cy="274320"/>
           </a:xfrm>
           <a:prstGeom prst="rect">
@@ -1822,7 +1780,7 @@
                 <a:ea typeface="맑은 고딕" pitchFamily="34" charset="-122"/>
                 <a:cs typeface="맑은 고딕" pitchFamily="34" charset="-120"/>
               </a:rPr>
-              <a:t>고객사 Value-Chain AI 과제 컨설팅  </a:t>
+              <a:t>자체 추진 대내·대외 컨설팅  </a:t>
             </a:r>
             <a:pPr indent="0" marL="0">
               <a:buNone/>
@@ -1836,7 +1794,7 @@
                 <a:ea typeface="맑은 고딕" pitchFamily="34" charset="-122"/>
                 <a:cs typeface="맑은 고딕" pitchFamily="34" charset="-120"/>
               </a:rPr>
-              <a:t>(6건)</a:t>
+              <a:t>(9건)</a:t>
             </a:r>
             <a:endParaRPr lang="en-US" sz="1250" dirty="0"/>
           </a:p>
@@ -1850,8 +1808,8 @@
         </p:nvSpPr>
         <p:spPr>
           <a:xfrm>
-            <a:off x="1161288" y="4425696"/>
-            <a:ext cx="3712464" cy="429768"/>
+            <a:off x="1161288" y="3575304"/>
+            <a:ext cx="3712464" cy="658368"/>
           </a:xfrm>
           <a:prstGeom prst="rect">
             <a:avLst/>
@@ -1865,7 +1823,7 @@
           <a:p>
             <a:pPr marL="127000" indent="-127000">
               <a:spcAft>
-                <a:spcPts val="200"/>
+                <a:spcPts val="100"/>
               </a:spcAft>
               <a:buSzPct val="100000"/>
               <a:buChar char="•"/>
@@ -1879,14 +1837,14 @@
                 <a:ea typeface="맑은 고딕" pitchFamily="34" charset="-122"/>
                 <a:cs typeface="맑은 고딕" pitchFamily="34" charset="-120"/>
               </a:rPr>
-              <a:t>백화점, 컬처웍스, LIT AX 과제 컨설팅</a:t>
+              <a:t>지주 연계 : 4차(케미칼), 마트·호텔 실행방안 상세화</a:t>
             </a:r>
             <a:endParaRPr lang="en-US" sz="1050" dirty="0"/>
           </a:p>
           <a:p>
             <a:pPr marL="127000" indent="-127000">
               <a:spcAft>
-                <a:spcPts val="200"/>
+                <a:spcPts val="100"/>
               </a:spcAft>
               <a:buSzPct val="100000"/>
               <a:buChar char="•"/>
@@ -1900,7 +1858,28 @@
                 <a:ea typeface="맑은 고딕" pitchFamily="34" charset="-122"/>
                 <a:cs typeface="맑은 고딕" pitchFamily="34" charset="-120"/>
               </a:rPr>
-              <a:t>대외 : 신분당선, KT&amp;G AI 컨설팅</a:t>
+              <a:t>자체 추진 : 홈쇼핑 GPU, 코리아세븐, 건설, 웰푸드</a:t>
+            </a:r>
+            <a:endParaRPr lang="en-US" sz="1050" dirty="0"/>
+          </a:p>
+          <a:p>
+            <a:pPr marL="127000" indent="-127000">
+              <a:spcAft>
+                <a:spcPts val="100"/>
+              </a:spcAft>
+              <a:buSzPct val="100000"/>
+              <a:buChar char="•"/>
+            </a:pPr>
+            <a:r>
+              <a:rPr lang="en-US" sz="1050" dirty="0">
+                <a:solidFill>
+                  <a:srgbClr val="3A3A3A"/>
+                </a:solidFill>
+                <a:latin typeface="맑은 고딕" pitchFamily="34" charset="0"/>
+                <a:ea typeface="맑은 고딕" pitchFamily="34" charset="-122"/>
+                <a:cs typeface="맑은 고딕" pitchFamily="34" charset="-120"/>
+              </a:rPr>
+              <a:t>대외 : 공항철도, 군인공제회 (예정 : HD현대 외 2)</a:t>
             </a:r>
             <a:endParaRPr lang="en-US" sz="1050" dirty="0"/>
           </a:p>
@@ -1914,7 +1893,213 @@
         </p:nvSpPr>
         <p:spPr>
           <a:xfrm>
-            <a:off x="539496" y="5065776"/>
+            <a:off x="539496" y="4425696"/>
+            <a:ext cx="237744" cy="237744"/>
+          </a:xfrm>
+          <a:prstGeom prst="ellipse">
+            <a:avLst/>
+          </a:prstGeom>
+          <a:solidFill>
+            <a:srgbClr val="FFFFFF"/>
+          </a:solidFill>
+          <a:ln w="38100">
+            <a:solidFill>
+              <a:srgbClr val="6E6E6E"/>
+            </a:solidFill>
+            <a:prstDash val="solid"/>
+          </a:ln>
+        </p:spPr>
+      </p:sp>
+      <p:sp>
+        <p:nvSpPr>
+          <p:cNvPr id="30" name="Text 28"/>
+          <p:cNvSpPr txBox="1"/>
+          <p:nvPr/>
+        </p:nvSpPr>
+        <p:spPr>
+          <a:xfrm>
+            <a:off x="320040" y="4700016"/>
+            <a:ext cx="685800" cy="228600"/>
+          </a:xfrm>
+          <a:prstGeom prst="rect">
+            <a:avLst/>
+          </a:prstGeom>
+          <a:noFill/>
+          <a:ln/>
+        </p:spPr>
+        <p:txBody>
+          <a:bodyPr wrap="square" lIns="0" tIns="0" rIns="0" bIns="0" rtlCol="0" anchor="ctr"/>
+          <a:lstStyle/>
+          <a:p>
+            <a:pPr algn="ctr" indent="0" marL="0">
+              <a:buNone/>
+            </a:pPr>
+            <a:r>
+              <a:rPr lang="en-US" sz="1100" b="1" dirty="0">
+                <a:solidFill>
+                  <a:srgbClr val="3A3A3A"/>
+                </a:solidFill>
+                <a:latin typeface="맑은 고딕" pitchFamily="34" charset="0"/>
+                <a:ea typeface="맑은 고딕" pitchFamily="34" charset="-122"/>
+                <a:cs typeface="맑은 고딕" pitchFamily="34" charset="-120"/>
+              </a:rPr>
+              <a:t>'26 상</a:t>
+            </a:r>
+            <a:endParaRPr lang="en-US" sz="1100" dirty="0"/>
+          </a:p>
+        </p:txBody>
+      </p:sp>
+      <p:sp>
+        <p:nvSpPr>
+          <p:cNvPr id="31" name="Shape 29"/>
+          <p:cNvSpPr/>
+          <p:nvPr/>
+        </p:nvSpPr>
+        <p:spPr>
+          <a:xfrm>
+            <a:off x="1051560" y="4352544"/>
+            <a:ext cx="3931920" cy="694944"/>
+          </a:xfrm>
+          <a:prstGeom prst="rect">
+            <a:avLst/>
+          </a:prstGeom>
+          <a:solidFill>
+            <a:srgbClr val="F2F2F2"/>
+          </a:solidFill>
+          <a:ln w="12700">
+            <a:solidFill>
+              <a:srgbClr val="F2F2F2"/>
+            </a:solidFill>
+            <a:prstDash val="solid"/>
+          </a:ln>
+        </p:spPr>
+      </p:sp>
+      <p:sp>
+        <p:nvSpPr>
+          <p:cNvPr id="32" name="Text 30"/>
+          <p:cNvSpPr txBox="1"/>
+          <p:nvPr/>
+        </p:nvSpPr>
+        <p:spPr>
+          <a:xfrm>
+            <a:off x="1161288" y="4416552"/>
+            <a:ext cx="3712464" cy="274320"/>
+          </a:xfrm>
+          <a:prstGeom prst="rect">
+            <a:avLst/>
+          </a:prstGeom>
+          <a:noFill/>
+          <a:ln/>
+        </p:spPr>
+        <p:txBody>
+          <a:bodyPr wrap="square" lIns="0" tIns="0" rIns="0" bIns="0" rtlCol="0" anchor="ctr"/>
+          <a:lstStyle/>
+          <a:p>
+            <a:pPr indent="0" marL="0">
+              <a:buNone/>
+            </a:pPr>
+            <a:r>
+              <a:rPr lang="en-US" sz="1250" b="1" dirty="0">
+                <a:solidFill>
+                  <a:srgbClr val="222222"/>
+                </a:solidFill>
+                <a:latin typeface="맑은 고딕" pitchFamily="34" charset="0"/>
+                <a:ea typeface="맑은 고딕" pitchFamily="34" charset="-122"/>
+                <a:cs typeface="맑은 고딕" pitchFamily="34" charset="-120"/>
+              </a:rPr>
+              <a:t>고객사 Value-Chain AI 과제 컨설팅  </a:t>
+            </a:r>
+            <a:pPr indent="0" marL="0">
+              <a:buNone/>
+            </a:pPr>
+            <a:r>
+              <a:rPr lang="en-US" sz="1250" b="1" dirty="0">
+                <a:solidFill>
+                  <a:srgbClr val="D7281E"/>
+                </a:solidFill>
+                <a:latin typeface="맑은 고딕" pitchFamily="34" charset="0"/>
+                <a:ea typeface="맑은 고딕" pitchFamily="34" charset="-122"/>
+                <a:cs typeface="맑은 고딕" pitchFamily="34" charset="-120"/>
+              </a:rPr>
+              <a:t>(6건)</a:t>
+            </a:r>
+            <a:endParaRPr lang="en-US" sz="1250" dirty="0"/>
+          </a:p>
+        </p:txBody>
+      </p:sp>
+      <p:sp>
+        <p:nvSpPr>
+          <p:cNvPr id="33" name="Text 31"/>
+          <p:cNvSpPr txBox="1"/>
+          <p:nvPr/>
+        </p:nvSpPr>
+        <p:spPr>
+          <a:xfrm>
+            <a:off x="1161288" y="4690872"/>
+            <a:ext cx="3712464" cy="329184"/>
+          </a:xfrm>
+          <a:prstGeom prst="rect">
+            <a:avLst/>
+          </a:prstGeom>
+          <a:noFill/>
+          <a:ln/>
+        </p:spPr>
+        <p:txBody>
+          <a:bodyPr wrap="square" lIns="0" tIns="0" rIns="0" bIns="0" rtlCol="0" anchor="t"/>
+          <a:lstStyle/>
+          <a:p>
+            <a:pPr marL="127000" indent="-127000">
+              <a:spcAft>
+                <a:spcPts val="100"/>
+              </a:spcAft>
+              <a:buSzPct val="100000"/>
+              <a:buChar char="•"/>
+            </a:pPr>
+            <a:r>
+              <a:rPr lang="en-US" sz="1050" dirty="0">
+                <a:solidFill>
+                  <a:srgbClr val="3A3A3A"/>
+                </a:solidFill>
+                <a:latin typeface="맑은 고딕" pitchFamily="34" charset="0"/>
+                <a:ea typeface="맑은 고딕" pitchFamily="34" charset="-122"/>
+                <a:cs typeface="맑은 고딕" pitchFamily="34" charset="-120"/>
+              </a:rPr>
+              <a:t>백화점, 컬처웍스, LIT AX 과제 컨설팅</a:t>
+            </a:r>
+            <a:endParaRPr lang="en-US" sz="1050" dirty="0"/>
+          </a:p>
+          <a:p>
+            <a:pPr marL="127000" indent="-127000">
+              <a:spcAft>
+                <a:spcPts val="100"/>
+              </a:spcAft>
+              <a:buSzPct val="100000"/>
+              <a:buChar char="•"/>
+            </a:pPr>
+            <a:r>
+              <a:rPr lang="en-US" sz="1050" dirty="0">
+                <a:solidFill>
+                  <a:srgbClr val="3A3A3A"/>
+                </a:solidFill>
+                <a:latin typeface="맑은 고딕" pitchFamily="34" charset="0"/>
+                <a:ea typeface="맑은 고딕" pitchFamily="34" charset="-122"/>
+                <a:cs typeface="맑은 고딕" pitchFamily="34" charset="-120"/>
+              </a:rPr>
+              <a:t>대외 : 신분당선, KT&amp;G AI 컨설팅</a:t>
+            </a:r>
+            <a:endParaRPr lang="en-US" sz="1050" dirty="0"/>
+          </a:p>
+        </p:txBody>
+      </p:sp>
+      <p:sp>
+        <p:nvSpPr>
+          <p:cNvPr id="34" name="Shape 32"/>
+          <p:cNvSpPr/>
+          <p:nvPr/>
+        </p:nvSpPr>
+        <p:spPr>
+          <a:xfrm>
+            <a:off x="539496" y="5212080"/>
             <a:ext cx="237744" cy="237744"/>
           </a:xfrm>
           <a:prstGeom prst="ellipse">
@@ -1933,13 +2118,13 @@
       </p:sp>
       <p:sp>
         <p:nvSpPr>
-          <p:cNvPr id="30" name="Text 28"/>
-          <p:cNvSpPr txBox="1"/>
-          <p:nvPr/>
-        </p:nvSpPr>
-        <p:spPr>
-          <a:xfrm>
-            <a:off x="320040" y="5340096"/>
+          <p:cNvPr id="35" name="Text 33"/>
+          <p:cNvSpPr txBox="1"/>
+          <p:nvPr/>
+        </p:nvSpPr>
+        <p:spPr>
+          <a:xfrm>
+            <a:off x="320040" y="5486400"/>
             <a:ext cx="685800" cy="228600"/>
           </a:xfrm>
           <a:prstGeom prst="rect">
@@ -1972,14 +2157,14 @@
       </p:sp>
       <p:sp>
         <p:nvSpPr>
-          <p:cNvPr id="31" name="Shape 29"/>
+          <p:cNvPr id="36" name="Shape 34"/>
           <p:cNvSpPr/>
           <p:nvPr/>
         </p:nvSpPr>
         <p:spPr>
           <a:xfrm>
-            <a:off x="1051560" y="4992624"/>
-            <a:ext cx="3931920" cy="841248"/>
+            <a:off x="1051560" y="5138928"/>
+            <a:ext cx="3931920" cy="694944"/>
           </a:xfrm>
           <a:prstGeom prst="rect">
             <a:avLst/>
@@ -1997,13 +2182,13 @@
       </p:sp>
       <p:sp>
         <p:nvSpPr>
-          <p:cNvPr id="32" name="Text 30"/>
-          <p:cNvSpPr txBox="1"/>
-          <p:nvPr/>
-        </p:nvSpPr>
-        <p:spPr>
-          <a:xfrm>
-            <a:off x="1161288" y="5056632"/>
+          <p:cNvPr id="37" name="Text 35"/>
+          <p:cNvSpPr txBox="1"/>
+          <p:nvPr/>
+        </p:nvSpPr>
+        <p:spPr>
+          <a:xfrm>
+            <a:off x="1161288" y="5202936"/>
             <a:ext cx="3712464" cy="274320"/>
           </a:xfrm>
           <a:prstGeom prst="rect">
@@ -2050,14 +2235,14 @@
       </p:sp>
       <p:sp>
         <p:nvSpPr>
-          <p:cNvPr id="33" name="Text 31"/>
-          <p:cNvSpPr txBox="1"/>
-          <p:nvPr/>
-        </p:nvSpPr>
-        <p:spPr>
-          <a:xfrm>
-            <a:off x="1161288" y="5358384"/>
-            <a:ext cx="3712464" cy="429768"/>
+          <p:cNvPr id="38" name="Text 36"/>
+          <p:cNvSpPr txBox="1"/>
+          <p:nvPr/>
+        </p:nvSpPr>
+        <p:spPr>
+          <a:xfrm>
+            <a:off x="1161288" y="5477256"/>
+            <a:ext cx="3712464" cy="329184"/>
           </a:xfrm>
           <a:prstGeom prst="rect">
             <a:avLst/>
@@ -2071,7 +2256,7 @@
           <a:p>
             <a:pPr marL="127000" indent="-127000">
               <a:spcAft>
-                <a:spcPts val="200"/>
+                <a:spcPts val="100"/>
               </a:spcAft>
               <a:buSzPct val="100000"/>
               <a:buChar char="•"/>
@@ -2092,7 +2277,7 @@
           <a:p>
             <a:pPr marL="127000" indent="-127000">
               <a:spcAft>
-                <a:spcPts val="200"/>
+                <a:spcPts val="100"/>
               </a:spcAft>
               <a:buSzPct val="100000"/>
               <a:buChar char="•"/>
@@ -2114,7 +2299,7 @@
       </p:sp>
       <p:sp>
         <p:nvSpPr>
-          <p:cNvPr id="34" name="Shape 32"/>
+          <p:cNvPr id="39" name="Shape 37"/>
           <p:cNvSpPr/>
           <p:nvPr/>
         </p:nvSpPr>
@@ -2139,7 +2324,7 @@
       </p:sp>
       <p:sp>
         <p:nvSpPr>
-          <p:cNvPr id="35" name="Shape 33"/>
+          <p:cNvPr id="40" name="Shape 38"/>
           <p:cNvSpPr/>
           <p:nvPr/>
         </p:nvSpPr>
@@ -2164,7 +2349,7 @@
       </p:sp>
       <p:sp>
         <p:nvSpPr>
-          <p:cNvPr id="36" name="Text 34"/>
+          <p:cNvPr id="41" name="Text 39"/>
           <p:cNvSpPr txBox="1"/>
           <p:nvPr/>
         </p:nvSpPr>
@@ -2203,7 +2388,7 @@
       </p:sp>
       <p:sp>
         <p:nvSpPr>
-          <p:cNvPr id="37" name="Shape 35"/>
+          <p:cNvPr id="42" name="Shape 40"/>
           <p:cNvSpPr/>
           <p:nvPr/>
         </p:nvSpPr>
@@ -2228,7 +2413,7 @@
       </p:sp>
       <p:sp>
         <p:nvSpPr>
-          <p:cNvPr id="38" name="Text 36"/>
+          <p:cNvPr id="43" name="Text 41"/>
           <p:cNvSpPr txBox="1"/>
           <p:nvPr/>
         </p:nvSpPr>
@@ -2267,7 +2452,7 @@
       </p:sp>
       <p:sp>
         <p:nvSpPr>
-          <p:cNvPr id="39" name="Shape 37"/>
+          <p:cNvPr id="44" name="Shape 42"/>
           <p:cNvSpPr/>
           <p:nvPr/>
         </p:nvSpPr>
@@ -2292,7 +2477,7 @@
       </p:sp>
       <p:sp>
         <p:nvSpPr>
-          <p:cNvPr id="40" name="Text 38"/>
+          <p:cNvPr id="45" name="Text 43"/>
           <p:cNvSpPr txBox="1"/>
           <p:nvPr/>
         </p:nvSpPr>
@@ -2331,7 +2516,7 @@
       </p:sp>
       <p:sp>
         <p:nvSpPr>
-          <p:cNvPr id="41" name="Shape 39"/>
+          <p:cNvPr id="46" name="Shape 44"/>
           <p:cNvSpPr/>
           <p:nvPr/>
         </p:nvSpPr>
@@ -2356,7 +2541,7 @@
       </p:sp>
       <p:sp>
         <p:nvSpPr>
-          <p:cNvPr id="42" name="Shape 40"/>
+          <p:cNvPr id="47" name="Shape 45"/>
           <p:cNvSpPr/>
           <p:nvPr/>
         </p:nvSpPr>
@@ -2381,7 +2566,7 @@
       </p:sp>
       <p:pic>
         <p:nvPicPr>
-          <p:cNvPr id="43" name="Image 0" descr="preencoded.png">    </p:cNvPr>
+          <p:cNvPr id="48" name="Image 0" descr="preencoded.png">    </p:cNvPr>
           <p:cNvPicPr>
             <a:picLocks noChangeAspect="1"/>
           </p:cNvPicPr>
@@ -2405,7 +2590,7 @@
       </p:pic>
       <p:sp>
         <p:nvSpPr>
-          <p:cNvPr id="44" name="Text 41"/>
+          <p:cNvPr id="49" name="Text 46"/>
           <p:cNvSpPr txBox="1"/>
           <p:nvPr/>
         </p:nvSpPr>
@@ -2444,7 +2629,7 @@
       </p:sp>
       <p:sp>
         <p:nvSpPr>
-          <p:cNvPr id="45" name="Shape 42"/>
+          <p:cNvPr id="50" name="Shape 47"/>
           <p:cNvSpPr/>
           <p:nvPr/>
         </p:nvSpPr>
@@ -2469,7 +2654,7 @@
       </p:sp>
       <p:sp>
         <p:nvSpPr>
-          <p:cNvPr id="46" name="Text 43"/>
+          <p:cNvPr id="51" name="Text 48"/>
           <p:cNvSpPr txBox="1"/>
           <p:nvPr/>
         </p:nvSpPr>
@@ -2525,7 +2710,7 @@
       </p:sp>
       <p:sp>
         <p:nvSpPr>
-          <p:cNvPr id="47" name="Text 44"/>
+          <p:cNvPr id="52" name="Text 49"/>
           <p:cNvSpPr txBox="1"/>
           <p:nvPr/>
         </p:nvSpPr>
@@ -2589,7 +2774,7 @@
       </p:sp>
       <p:sp>
         <p:nvSpPr>
-          <p:cNvPr id="48" name="Shape 45"/>
+          <p:cNvPr id="53" name="Shape 50"/>
           <p:cNvSpPr/>
           <p:nvPr/>
         </p:nvSpPr>
@@ -2614,7 +2799,7 @@
       </p:sp>
       <p:sp>
         <p:nvSpPr>
-          <p:cNvPr id="49" name="Shape 46"/>
+          <p:cNvPr id="54" name="Shape 51"/>
           <p:cNvSpPr/>
           <p:nvPr/>
         </p:nvSpPr>
@@ -2639,7 +2824,7 @@
       </p:sp>
       <p:sp>
         <p:nvSpPr>
-          <p:cNvPr id="50" name="Text 47"/>
+          <p:cNvPr id="55" name="Text 52"/>
           <p:cNvSpPr txBox="1"/>
           <p:nvPr/>
         </p:nvSpPr>
@@ -2678,7 +2863,7 @@
       </p:sp>
       <p:sp>
         <p:nvSpPr>
-          <p:cNvPr id="51" name="Shape 48"/>
+          <p:cNvPr id="56" name="Shape 53"/>
           <p:cNvSpPr/>
           <p:nvPr/>
         </p:nvSpPr>
@@ -2703,7 +2888,7 @@
       </p:sp>
       <p:sp>
         <p:nvSpPr>
-          <p:cNvPr id="52" name="Text 49"/>
+          <p:cNvPr id="57" name="Text 54"/>
           <p:cNvSpPr txBox="1"/>
           <p:nvPr/>
         </p:nvSpPr>
@@ -2742,7 +2927,7 @@
       </p:sp>
       <p:sp>
         <p:nvSpPr>
-          <p:cNvPr id="53" name="Shape 50"/>
+          <p:cNvPr id="58" name="Shape 55"/>
           <p:cNvSpPr/>
           <p:nvPr/>
         </p:nvSpPr>
@@ -2767,7 +2952,7 @@
       </p:sp>
       <p:sp>
         <p:nvSpPr>
-          <p:cNvPr id="54" name="Shape 51"/>
+          <p:cNvPr id="59" name="Shape 56"/>
           <p:cNvSpPr/>
           <p:nvPr/>
         </p:nvSpPr>
@@ -2792,7 +2977,7 @@
       </p:sp>
       <p:pic>
         <p:nvPicPr>
-          <p:cNvPr id="55" name="Image 1" descr="preencoded.png">    </p:cNvPr>
+          <p:cNvPr id="60" name="Image 1" descr="preencoded.png">    </p:cNvPr>
           <p:cNvPicPr>
             <a:picLocks noChangeAspect="1"/>
           </p:cNvPicPr>
@@ -2816,7 +3001,7 @@
       </p:pic>
       <p:sp>
         <p:nvSpPr>
-          <p:cNvPr id="56" name="Text 52"/>
+          <p:cNvPr id="61" name="Text 57"/>
           <p:cNvSpPr txBox="1"/>
           <p:nvPr/>
         </p:nvSpPr>
@@ -2855,7 +3040,7 @@
       </p:sp>
       <p:sp>
         <p:nvSpPr>
-          <p:cNvPr id="57" name="Shape 53"/>
+          <p:cNvPr id="62" name="Shape 58"/>
           <p:cNvSpPr/>
           <p:nvPr/>
         </p:nvSpPr>
@@ -2880,7 +3065,7 @@
       </p:sp>
       <p:sp>
         <p:nvSpPr>
-          <p:cNvPr id="58" name="Text 54"/>
+          <p:cNvPr id="63" name="Text 59"/>
           <p:cNvSpPr txBox="1"/>
           <p:nvPr/>
         </p:nvSpPr>
@@ -2936,7 +3121,7 @@
       </p:sp>
       <p:sp>
         <p:nvSpPr>
-          <p:cNvPr id="59" name="Text 55"/>
+          <p:cNvPr id="64" name="Text 60"/>
           <p:cNvSpPr txBox="1"/>
           <p:nvPr/>
         </p:nvSpPr>
@@ -3000,7 +3185,7 @@
       </p:sp>
       <p:sp>
         <p:nvSpPr>
-          <p:cNvPr id="60" name="Shape 56"/>
+          <p:cNvPr id="65" name="Shape 61"/>
           <p:cNvSpPr/>
           <p:nvPr/>
         </p:nvSpPr>
@@ -3025,7 +3210,7 @@
       </p:sp>
       <p:sp>
         <p:nvSpPr>
-          <p:cNvPr id="61" name="Shape 57"/>
+          <p:cNvPr id="66" name="Shape 62"/>
           <p:cNvSpPr/>
           <p:nvPr/>
         </p:nvSpPr>
@@ -3050,7 +3235,7 @@
       </p:sp>
       <p:sp>
         <p:nvSpPr>
-          <p:cNvPr id="62" name="Text 58"/>
+          <p:cNvPr id="67" name="Text 63"/>
           <p:cNvSpPr txBox="1"/>
           <p:nvPr/>
         </p:nvSpPr>
@@ -3089,7 +3274,7 @@
       </p:sp>
       <p:sp>
         <p:nvSpPr>
-          <p:cNvPr id="63" name="Shape 59"/>
+          <p:cNvPr id="68" name="Shape 64"/>
           <p:cNvSpPr/>
           <p:nvPr/>
         </p:nvSpPr>
@@ -3114,7 +3299,7 @@
       </p:sp>
       <p:sp>
         <p:nvSpPr>
-          <p:cNvPr id="64" name="Text 60"/>
+          <p:cNvPr id="69" name="Text 65"/>
           <p:cNvSpPr txBox="1"/>
           <p:nvPr/>
         </p:nvSpPr>
@@ -3153,7 +3338,7 @@
       </p:sp>
       <p:sp>
         <p:nvSpPr>
-          <p:cNvPr id="65" name="Shape 61"/>
+          <p:cNvPr id="70" name="Shape 66"/>
           <p:cNvSpPr/>
           <p:nvPr/>
         </p:nvSpPr>
@@ -3178,7 +3363,7 @@
       </p:sp>
       <p:sp>
         <p:nvSpPr>
-          <p:cNvPr id="66" name="Shape 62"/>
+          <p:cNvPr id="71" name="Shape 67"/>
           <p:cNvSpPr/>
           <p:nvPr/>
         </p:nvSpPr>
@@ -3203,7 +3388,7 @@
       </p:sp>
       <p:pic>
         <p:nvPicPr>
-          <p:cNvPr id="67" name="Image 2" descr="preencoded.png">    </p:cNvPr>
+          <p:cNvPr id="72" name="Image 2" descr="preencoded.png">    </p:cNvPr>
           <p:cNvPicPr>
             <a:picLocks noChangeAspect="1"/>
           </p:cNvPicPr>
@@ -3227,7 +3412,7 @@
       </p:pic>
       <p:sp>
         <p:nvSpPr>
-          <p:cNvPr id="68" name="Text 63"/>
+          <p:cNvPr id="73" name="Text 68"/>
           <p:cNvSpPr txBox="1"/>
           <p:nvPr/>
         </p:nvSpPr>
@@ -3266,7 +3451,7 @@
       </p:sp>
       <p:sp>
         <p:nvSpPr>
-          <p:cNvPr id="69" name="Shape 64"/>
+          <p:cNvPr id="74" name="Shape 69"/>
           <p:cNvSpPr/>
           <p:nvPr/>
         </p:nvSpPr>
@@ -3291,7 +3476,7 @@
       </p:sp>
       <p:sp>
         <p:nvSpPr>
-          <p:cNvPr id="70" name="Text 65"/>
+          <p:cNvPr id="75" name="Text 70"/>
           <p:cNvSpPr txBox="1"/>
           <p:nvPr/>
         </p:nvSpPr>
@@ -3347,7 +3532,7 @@
       </p:sp>
       <p:sp>
         <p:nvSpPr>
-          <p:cNvPr id="71" name="Text 66"/>
+          <p:cNvPr id="76" name="Text 71"/>
           <p:cNvSpPr txBox="1"/>
           <p:nvPr/>
         </p:nvSpPr>
@@ -3411,7 +3596,7 @@
       </p:sp>
       <p:sp>
         <p:nvSpPr>
-          <p:cNvPr id="72" name="Shape 67"/>
+          <p:cNvPr id="77" name="Shape 72"/>
           <p:cNvSpPr/>
           <p:nvPr/>
         </p:nvSpPr>
@@ -3436,7 +3621,7 @@
       </p:sp>
       <p:sp>
         <p:nvSpPr>
-          <p:cNvPr id="73" name="Shape 68"/>
+          <p:cNvPr id="78" name="Shape 73"/>
           <p:cNvSpPr/>
           <p:nvPr/>
         </p:nvSpPr>
@@ -3461,7 +3646,7 @@
       </p:sp>
       <p:sp>
         <p:nvSpPr>
-          <p:cNvPr id="74" name="Text 69"/>
+          <p:cNvPr id="79" name="Text 74"/>
           <p:cNvSpPr txBox="1"/>
           <p:nvPr/>
         </p:nvSpPr>
@@ -3500,7 +3685,7 @@
       </p:sp>
       <p:sp>
         <p:nvSpPr>
-          <p:cNvPr id="75" name="Shape 70"/>
+          <p:cNvPr id="80" name="Shape 75"/>
           <p:cNvSpPr/>
           <p:nvPr/>
         </p:nvSpPr>
@@ -3525,7 +3710,7 @@
       </p:sp>
       <p:sp>
         <p:nvSpPr>
-          <p:cNvPr id="76" name="Text 71"/>
+          <p:cNvPr id="81" name="Text 76"/>
           <p:cNvSpPr txBox="1"/>
           <p:nvPr/>
         </p:nvSpPr>
@@ -3564,7 +3749,7 @@
       </p:sp>
       <p:sp>
         <p:nvSpPr>
-          <p:cNvPr id="77" name="Shape 72"/>
+          <p:cNvPr id="82" name="Shape 77"/>
           <p:cNvSpPr/>
           <p:nvPr/>
         </p:nvSpPr>
@@ -3589,7 +3774,7 @@
       </p:sp>
       <p:sp>
         <p:nvSpPr>
-          <p:cNvPr id="78" name="Shape 73"/>
+          <p:cNvPr id="83" name="Shape 78"/>
           <p:cNvSpPr/>
           <p:nvPr/>
         </p:nvSpPr>
@@ -3614,7 +3799,7 @@
       </p:sp>
       <p:pic>
         <p:nvPicPr>
-          <p:cNvPr id="79" name="Image 3" descr="preencoded.png">    </p:cNvPr>
+          <p:cNvPr id="84" name="Image 3" descr="preencoded.png">    </p:cNvPr>
           <p:cNvPicPr>
             <a:picLocks noChangeAspect="1"/>
           </p:cNvPicPr>
@@ -3638,7 +3823,7 @@
       </p:pic>
       <p:sp>
         <p:nvSpPr>
-          <p:cNvPr id="80" name="Text 74"/>
+          <p:cNvPr id="85" name="Text 79"/>
           <p:cNvSpPr txBox="1"/>
           <p:nvPr/>
         </p:nvSpPr>
@@ -3677,7 +3862,7 @@
       </p:sp>
       <p:sp>
         <p:nvSpPr>
-          <p:cNvPr id="81" name="Shape 75"/>
+          <p:cNvPr id="86" name="Shape 80"/>
           <p:cNvSpPr/>
           <p:nvPr/>
         </p:nvSpPr>
@@ -3702,7 +3887,7 @@
       </p:sp>
       <p:sp>
         <p:nvSpPr>
-          <p:cNvPr id="82" name="Text 76"/>
+          <p:cNvPr id="87" name="Text 81"/>
           <p:cNvSpPr txBox="1"/>
           <p:nvPr/>
         </p:nvSpPr>
@@ -3758,7 +3943,7 @@
       </p:sp>
       <p:sp>
         <p:nvSpPr>
-          <p:cNvPr id="83" name="Text 77"/>
+          <p:cNvPr id="88" name="Text 82"/>
           <p:cNvSpPr txBox="1"/>
           <p:nvPr/>
         </p:nvSpPr>
@@ -3822,7 +4007,7 @@
       </p:sp>
       <p:sp>
         <p:nvSpPr>
-          <p:cNvPr id="84" name="Shape 78"/>
+          <p:cNvPr id="89" name="Shape 83"/>
           <p:cNvSpPr/>
           <p:nvPr/>
         </p:nvSpPr>
@@ -3847,7 +4032,7 @@
       </p:sp>
       <p:sp>
         <p:nvSpPr>
-          <p:cNvPr id="85" name="Shape 79"/>
+          <p:cNvPr id="90" name="Shape 84"/>
           <p:cNvSpPr/>
           <p:nvPr/>
         </p:nvSpPr>
@@ -3872,7 +4057,7 @@
       </p:sp>
       <p:sp>
         <p:nvSpPr>
-          <p:cNvPr id="86" name="Text 80"/>
+          <p:cNvPr id="91" name="Text 85"/>
           <p:cNvSpPr txBox="1"/>
           <p:nvPr/>
         </p:nvSpPr>
@@ -3911,7 +4096,7 @@
       </p:sp>
       <p:sp>
         <p:nvSpPr>
-          <p:cNvPr id="87" name="Shape 81"/>
+          <p:cNvPr id="92" name="Shape 86"/>
           <p:cNvSpPr/>
           <p:nvPr/>
         </p:nvSpPr>
@@ -3936,7 +4121,7 @@
       </p:sp>
       <p:sp>
         <p:nvSpPr>
-          <p:cNvPr id="88" name="Text 82"/>
+          <p:cNvPr id="93" name="Text 87"/>
           <p:cNvSpPr txBox="1"/>
           <p:nvPr/>
         </p:nvSpPr>
@@ -3975,7 +4160,7 @@
       </p:sp>
       <p:sp>
         <p:nvSpPr>
-          <p:cNvPr id="89" name="Shape 83"/>
+          <p:cNvPr id="94" name="Shape 88"/>
           <p:cNvSpPr/>
           <p:nvPr/>
         </p:nvSpPr>
@@ -4000,7 +4185,7 @@
       </p:sp>
       <p:sp>
         <p:nvSpPr>
-          <p:cNvPr id="90" name="Text 84"/>
+          <p:cNvPr id="95" name="Text 89"/>
           <p:cNvSpPr txBox="1"/>
           <p:nvPr/>
         </p:nvSpPr>

</xml_diff>